<commit_message>
Presentazione aggiornata e file readme.md creato
</commit_message>
<xml_diff>
--- a/Spotify Tracks Dataset.pptx
+++ b/Spotify Tracks Dataset.pptx
@@ -110,6 +110,11 @@
       </a:defRPr>
     </a:lvl9pPr>
   </p:defaultTextStyle>
+  <p:extLst>
+    <p:ext uri="{EFAFB233-063F-42B5-8137-9DF3F51BA10A}">
+      <p15:sldGuideLst xmlns:p15="http://schemas.microsoft.com/office/powerpoint/2012/main"/>
+    </p:ext>
+  </p:extLst>
 </p:presentation>
 </file>
 
@@ -195,7 +200,7 @@
           <a:p>
             <a:fld id="{A0B6E5F0-6A36-4198-8838-CB73C43E7E33}" type="datetimeFigureOut">
               <a:rPr lang="it-CH" smtClean="0"/>
-              <a:t>06.05.2026</a:t>
+              <a:t>07.05.2026</a:t>
             </a:fld>
             <a:endParaRPr lang="it-CH"/>
           </a:p>
@@ -354,7 +359,7 @@
           <a:p>
             <a:fld id="{8BE94A0A-3E9B-4675-9F00-F14DBC49534D}" type="slidenum">
               <a:rPr lang="it-CH" smtClean="0"/>
-              <a:t>‹#›</a:t>
+              <a:t>‹N›</a:t>
             </a:fld>
             <a:endParaRPr lang="it-CH"/>
           </a:p>
@@ -482,6 +487,101 @@
       </p:grpSpPr>
       <p:sp>
         <p:nvSpPr>
+          <p:cNvPr id="2" name="Segnaposto immagine diapositiva 1"/>
+          <p:cNvSpPr>
+            <a:spLocks noGrp="1" noRot="1" noChangeAspect="1"/>
+          </p:cNvSpPr>
+          <p:nvPr>
+            <p:ph type="sldImg"/>
+          </p:nvPr>
+        </p:nvSpPr>
+        <p:spPr/>
+      </p:sp>
+      <p:sp>
+        <p:nvSpPr>
+          <p:cNvPr id="3" name="Segnaposto note 2"/>
+          <p:cNvSpPr>
+            <a:spLocks noGrp="1"/>
+          </p:cNvSpPr>
+          <p:nvPr>
+            <p:ph type="body" idx="1"/>
+          </p:nvPr>
+        </p:nvSpPr>
+        <p:spPr/>
+        <p:txBody>
+          <a:bodyPr/>
+          <a:lstStyle/>
+          <a:p>
+            <a:r>
+              <a:rPr lang="it-CH" dirty="0"/>
+              <a:t>Fare ascoltare le canzoni per fare capire </a:t>
+            </a:r>
+            <a:r>
+              <a:rPr lang="it-CH" dirty="0" err="1"/>
+              <a:t>danceability</a:t>
+            </a:r>
+            <a:r>
+              <a:rPr lang="it-CH" dirty="0"/>
+              <a:t> e energy</a:t>
+            </a:r>
+          </a:p>
+        </p:txBody>
+      </p:sp>
+      <p:sp>
+        <p:nvSpPr>
+          <p:cNvPr id="4" name="Segnaposto numero diapositiva 3"/>
+          <p:cNvSpPr>
+            <a:spLocks noGrp="1"/>
+          </p:cNvSpPr>
+          <p:nvPr>
+            <p:ph type="sldNum" sz="quarter" idx="5"/>
+          </p:nvPr>
+        </p:nvSpPr>
+        <p:spPr/>
+        <p:txBody>
+          <a:bodyPr/>
+          <a:lstStyle/>
+          <a:p>
+            <a:fld id="{8BE94A0A-3E9B-4675-9F00-F14DBC49534D}" type="slidenum">
+              <a:rPr lang="it-CH" smtClean="0"/>
+              <a:t>3</a:t>
+            </a:fld>
+            <a:endParaRPr lang="it-CH"/>
+          </a:p>
+        </p:txBody>
+      </p:sp>
+    </p:spTree>
+    <p:extLst>
+      <p:ext uri="{BB962C8B-B14F-4D97-AF65-F5344CB8AC3E}">
+        <p14:creationId xmlns:p14="http://schemas.microsoft.com/office/powerpoint/2010/main" val="1959867000"/>
+      </p:ext>
+    </p:extLst>
+  </p:cSld>
+  <p:clrMapOvr>
+    <a:masterClrMapping/>
+  </p:clrMapOvr>
+</p:notes>
+</file>
+
+<file path=ppt/notesSlides/notesSlide2.xml><?xml version="1.0" encoding="utf-8"?>
+<p:notes xmlns:a="http://schemas.openxmlformats.org/drawingml/2006/main" xmlns:r="http://schemas.openxmlformats.org/officeDocument/2006/relationships" xmlns:p="http://schemas.openxmlformats.org/presentationml/2006/main">
+  <p:cSld>
+    <p:spTree>
+      <p:nvGrpSpPr>
+        <p:cNvPr id="1" name=""/>
+        <p:cNvGrpSpPr/>
+        <p:nvPr/>
+      </p:nvGrpSpPr>
+      <p:grpSpPr>
+        <a:xfrm>
+          <a:off x="0" y="0"/>
+          <a:ext cx="0" cy="0"/>
+          <a:chOff x="0" y="0"/>
+          <a:chExt cx="0" cy="0"/>
+        </a:xfrm>
+      </p:grpSpPr>
+      <p:sp>
+        <p:nvSpPr>
           <p:cNvPr id="2" name="Slide Image Placeholder 1"/>
           <p:cNvSpPr>
             <a:spLocks noGrp="1" noRot="1" noChangeAspect="1"/>
@@ -523,11 +623,17 @@
             </a:br>
             <a:r>
               <a:rPr lang="it-IT" dirty="0"/>
-              <a:t>L’obiettivo è capire quali variabili sono collegate tra loro e quali influenzano maggiormente il successo di un brano. </a:t>
+              <a:t>L’obiettivo è capire quali variabili sono collegate tra loro e quali influenzano maggiormente il successo di un brano.</a:t>
+            </a:r>
+          </a:p>
+          <a:p>
+            <a:r>
+              <a:rPr lang="it-IT" b="1" dirty="0" err="1"/>
+              <a:t>Scatter</a:t>
             </a:r>
             <a:r>
               <a:rPr lang="it-IT" b="1" dirty="0"/>
-              <a:t>Scatter Plot tra Danceability e Popularity</a:t>
+              <a:t> Plot tra Danceability e Popularity</a:t>
             </a:r>
             <a:br>
               <a:rPr lang="it-IT" dirty="0"/>
@@ -541,8 +647,10 @@
             </a:br>
             <a:r>
               <a:rPr lang="it-IT" dirty="0"/>
-              <a:t>Può aiutare a capire se le canzoni più adatte al ballo tendono ad essere anche le più ascoltate. </a:t>
-            </a:r>
+              <a:t>Può aiutare a capire se le canzoni più adatte al ballo tendono ad essere anche le più ascoltate.</a:t>
+            </a:r>
+          </a:p>
+          <a:p>
             <a:r>
               <a:rPr lang="it-IT" b="1" dirty="0"/>
               <a:t>Box Plot dell’Energy per genere musicale</a:t>
@@ -558,10 +666,10 @@
               <a:rPr lang="it-IT" dirty="0"/>
             </a:br>
             <a:r>
-              <a:rPr lang="it-IT"/>
+              <a:rPr lang="it-IT" dirty="0"/>
               <a:t>Permette di osservare differenze tra i generi e identificare quali tipi di musica tendono ad essere più intensi o dinamici.</a:t>
             </a:r>
-            <a:endParaRPr lang="it-CH"/>
+            <a:endParaRPr lang="it-CH" dirty="0"/>
           </a:p>
         </p:txBody>
       </p:sp>
@@ -787,7 +895,7 @@
           <a:p>
             <a:fld id="{4AAD347D-5ACD-4C99-B74B-A9C85AD731AF}" type="datetimeFigureOut">
               <a:rPr lang="en-US" dirty="0"/>
-              <a:t>5/6/2026</a:t>
+              <a:t>5/7/2026</a:t>
             </a:fld>
             <a:endParaRPr lang="en-US" dirty="0"/>
           </a:p>
@@ -829,7 +937,7 @@
           <a:p>
             <a:fld id="{D57F1E4F-1CFF-5643-939E-02111984F565}" type="slidenum">
               <a:rPr lang="en-US" dirty="0"/>
-              <a:t>‹#›</a:t>
+              <a:t>‹N›</a:t>
             </a:fld>
             <a:endParaRPr lang="en-US" dirty="0"/>
           </a:p>
@@ -1057,7 +1165,7 @@
           <a:p>
             <a:fld id="{4509A250-FF31-4206-8172-F9D3106AACB1}" type="datetimeFigureOut">
               <a:rPr lang="en-US" dirty="0"/>
-              <a:t>5/6/2026</a:t>
+              <a:t>5/7/2026</a:t>
             </a:fld>
             <a:endParaRPr lang="en-US" dirty="0"/>
           </a:p>
@@ -1099,7 +1207,7 @@
           <a:p>
             <a:fld id="{D57F1E4F-1CFF-5643-939E-02111984F565}" type="slidenum">
               <a:rPr lang="en-US" dirty="0"/>
-              <a:t>‹#›</a:t>
+              <a:t>‹N›</a:t>
             </a:fld>
             <a:endParaRPr lang="en-US" dirty="0"/>
           </a:p>
@@ -1246,7 +1354,7 @@
           <a:p>
             <a:fld id="{4509A250-FF31-4206-8172-F9D3106AACB1}" type="datetimeFigureOut">
               <a:rPr lang="en-US" dirty="0"/>
-              <a:t>5/6/2026</a:t>
+              <a:t>5/7/2026</a:t>
             </a:fld>
             <a:endParaRPr lang="en-US" dirty="0"/>
           </a:p>
@@ -1288,7 +1396,7 @@
           <a:p>
             <a:fld id="{D57F1E4F-1CFF-5643-939E-02111984F565}" type="slidenum">
               <a:rPr lang="en-US" dirty="0"/>
-              <a:t>‹#›</a:t>
+              <a:t>‹N›</a:t>
             </a:fld>
             <a:endParaRPr lang="en-US" dirty="0"/>
           </a:p>
@@ -1514,7 +1622,7 @@
           <a:p>
             <a:fld id="{4509A250-FF31-4206-8172-F9D3106AACB1}" type="datetimeFigureOut">
               <a:rPr lang="en-US" dirty="0"/>
-              <a:t>5/6/2026</a:t>
+              <a:t>5/7/2026</a:t>
             </a:fld>
             <a:endParaRPr lang="en-US" dirty="0"/>
           </a:p>
@@ -1556,7 +1664,7 @@
           <a:p>
             <a:fld id="{D57F1E4F-1CFF-5643-939E-02111984F565}" type="slidenum">
               <a:rPr lang="en-US" dirty="0"/>
-              <a:t>‹#›</a:t>
+              <a:t>‹N›</a:t>
             </a:fld>
             <a:endParaRPr lang="en-US" dirty="0"/>
           </a:p>
@@ -1850,7 +1958,7 @@
           <a:p>
             <a:fld id="{4509A250-FF31-4206-8172-F9D3106AACB1}" type="datetimeFigureOut">
               <a:rPr lang="en-US" dirty="0"/>
-              <a:t>5/6/2026</a:t>
+              <a:t>5/7/2026</a:t>
             </a:fld>
             <a:endParaRPr lang="en-US" dirty="0"/>
           </a:p>
@@ -1892,7 +2000,7 @@
           <a:p>
             <a:fld id="{D57F1E4F-1CFF-5643-939E-02111984F565}" type="slidenum">
               <a:rPr lang="en-US" dirty="0"/>
-              <a:t>‹#›</a:t>
+              <a:t>‹N›</a:t>
             </a:fld>
             <a:endParaRPr lang="en-US" dirty="0"/>
           </a:p>
@@ -2468,7 +2576,7 @@
           <a:p>
             <a:fld id="{4509A250-FF31-4206-8172-F9D3106AACB1}" type="datetimeFigureOut">
               <a:rPr lang="en-US" dirty="0"/>
-              <a:t>5/6/2026</a:t>
+              <a:t>5/7/2026</a:t>
             </a:fld>
             <a:endParaRPr lang="en-US" dirty="0"/>
           </a:p>
@@ -2510,7 +2618,7 @@
           <a:p>
             <a:fld id="{D57F1E4F-1CFF-5643-939E-02111984F565}" type="slidenum">
               <a:rPr lang="en-US" dirty="0"/>
-              <a:t>‹#›</a:t>
+              <a:t>‹N›</a:t>
             </a:fld>
             <a:endParaRPr lang="en-US" dirty="0"/>
           </a:p>
@@ -3323,7 +3431,7 @@
           <a:p>
             <a:fld id="{4509A250-FF31-4206-8172-F9D3106AACB1}" type="datetimeFigureOut">
               <a:rPr lang="en-US" dirty="0"/>
-              <a:t>5/6/2026</a:t>
+              <a:t>5/7/2026</a:t>
             </a:fld>
             <a:endParaRPr lang="en-US" dirty="0"/>
           </a:p>
@@ -3365,7 +3473,7 @@
           <a:p>
             <a:fld id="{D57F1E4F-1CFF-5643-939E-02111984F565}" type="slidenum">
               <a:rPr lang="en-US" dirty="0"/>
-              <a:t>‹#›</a:t>
+              <a:t>‹N›</a:t>
             </a:fld>
             <a:endParaRPr lang="en-US" dirty="0"/>
           </a:p>
@@ -3488,7 +3596,7 @@
           <a:p>
             <a:fld id="{4509A250-FF31-4206-8172-F9D3106AACB1}" type="datetimeFigureOut">
               <a:rPr lang="en-US" dirty="0"/>
-              <a:t>5/6/2026</a:t>
+              <a:t>5/7/2026</a:t>
             </a:fld>
             <a:endParaRPr lang="en-US" dirty="0"/>
           </a:p>
@@ -3530,7 +3638,7 @@
           <a:p>
             <a:fld id="{D57F1E4F-1CFF-5643-939E-02111984F565}" type="slidenum">
               <a:rPr lang="en-US" dirty="0"/>
-              <a:t>‹#›</a:t>
+              <a:t>‹N›</a:t>
             </a:fld>
             <a:endParaRPr lang="en-US" dirty="0"/>
           </a:p>
@@ -3663,7 +3771,7 @@
           <a:p>
             <a:fld id="{4509A250-FF31-4206-8172-F9D3106AACB1}" type="datetimeFigureOut">
               <a:rPr lang="en-US" dirty="0"/>
-              <a:t>5/6/2026</a:t>
+              <a:t>5/7/2026</a:t>
             </a:fld>
             <a:endParaRPr lang="en-US" dirty="0"/>
           </a:p>
@@ -3705,7 +3813,7 @@
           <a:p>
             <a:fld id="{D57F1E4F-1CFF-5643-939E-02111984F565}" type="slidenum">
               <a:rPr lang="en-US" dirty="0"/>
-              <a:t>‹#›</a:t>
+              <a:t>‹N›</a:t>
             </a:fld>
             <a:endParaRPr lang="en-US" dirty="0"/>
           </a:p>
@@ -3828,7 +3936,7 @@
           <a:p>
             <a:fld id="{4509A250-FF31-4206-8172-F9D3106AACB1}" type="datetimeFigureOut">
               <a:rPr lang="en-US" dirty="0"/>
-              <a:t>5/6/2026</a:t>
+              <a:t>5/7/2026</a:t>
             </a:fld>
             <a:endParaRPr lang="en-US" dirty="0"/>
           </a:p>
@@ -3870,7 +3978,7 @@
           <a:p>
             <a:fld id="{D57F1E4F-1CFF-5643-939E-02111984F565}" type="slidenum">
               <a:rPr lang="en-US" dirty="0"/>
-              <a:t>‹#›</a:t>
+              <a:t>‹N›</a:t>
             </a:fld>
             <a:endParaRPr lang="en-US" dirty="0"/>
           </a:p>
@@ -4070,7 +4178,7 @@
           <a:p>
             <a:fld id="{9796027F-7875-4030-9381-8BD8C4F21935}" type="datetimeFigureOut">
               <a:rPr lang="en-US" dirty="0"/>
-              <a:t>5/6/2026</a:t>
+              <a:t>5/7/2026</a:t>
             </a:fld>
             <a:endParaRPr lang="en-US" dirty="0"/>
           </a:p>
@@ -4112,7 +4220,7 @@
           <a:p>
             <a:fld id="{D57F1E4F-1CFF-5643-939E-02111984F565}" type="slidenum">
               <a:rPr lang="en-US" dirty="0"/>
-              <a:t>‹#›</a:t>
+              <a:t>‹N›</a:t>
             </a:fld>
             <a:endParaRPr lang="en-US" dirty="0"/>
           </a:p>
@@ -4357,7 +4465,7 @@
           <a:p>
             <a:fld id="{9796027F-7875-4030-9381-8BD8C4F21935}" type="datetimeFigureOut">
               <a:rPr lang="en-US" dirty="0"/>
-              <a:t>5/6/2026</a:t>
+              <a:t>5/7/2026</a:t>
             </a:fld>
             <a:endParaRPr lang="en-US" dirty="0"/>
           </a:p>
@@ -4399,7 +4507,7 @@
           <a:p>
             <a:fld id="{D57F1E4F-1CFF-5643-939E-02111984F565}" type="slidenum">
               <a:rPr lang="en-US" dirty="0"/>
-              <a:t>‹#›</a:t>
+              <a:t>‹N›</a:t>
             </a:fld>
             <a:endParaRPr lang="en-US" dirty="0"/>
           </a:p>
@@ -4796,7 +4904,7 @@
           <a:p>
             <a:fld id="{9796027F-7875-4030-9381-8BD8C4F21935}" type="datetimeFigureOut">
               <a:rPr lang="en-US" dirty="0"/>
-              <a:t>5/6/2026</a:t>
+              <a:t>5/7/2026</a:t>
             </a:fld>
             <a:endParaRPr lang="en-US" dirty="0"/>
           </a:p>
@@ -4838,7 +4946,7 @@
           <a:p>
             <a:fld id="{D57F1E4F-1CFF-5643-939E-02111984F565}" type="slidenum">
               <a:rPr lang="en-US" dirty="0"/>
-              <a:t>‹#›</a:t>
+              <a:t>‹N›</a:t>
             </a:fld>
             <a:endParaRPr lang="en-US" dirty="0"/>
           </a:p>
@@ -4909,7 +5017,7 @@
           <a:p>
             <a:fld id="{4509A250-FF31-4206-8172-F9D3106AACB1}" type="datetimeFigureOut">
               <a:rPr lang="en-US" dirty="0"/>
-              <a:t>5/6/2026</a:t>
+              <a:t>5/7/2026</a:t>
             </a:fld>
             <a:endParaRPr lang="en-US" dirty="0"/>
           </a:p>
@@ -4951,7 +5059,7 @@
           <a:p>
             <a:fld id="{D57F1E4F-1CFF-5643-939E-02111984F565}" type="slidenum">
               <a:rPr lang="en-US" dirty="0"/>
-              <a:t>‹#›</a:t>
+              <a:t>‹N›</a:t>
             </a:fld>
             <a:endParaRPr lang="en-US" dirty="0"/>
           </a:p>
@@ -4999,7 +5107,7 @@
           <a:p>
             <a:fld id="{4509A250-FF31-4206-8172-F9D3106AACB1}" type="datetimeFigureOut">
               <a:rPr lang="en-US" dirty="0"/>
-              <a:t>5/6/2026</a:t>
+              <a:t>5/7/2026</a:t>
             </a:fld>
             <a:endParaRPr lang="en-US" dirty="0"/>
           </a:p>
@@ -5041,7 +5149,7 @@
           <a:p>
             <a:fld id="{D57F1E4F-1CFF-5643-939E-02111984F565}" type="slidenum">
               <a:rPr lang="en-US" dirty="0"/>
-              <a:t>‹#›</a:t>
+              <a:t>‹N›</a:t>
             </a:fld>
             <a:endParaRPr lang="en-US" dirty="0"/>
           </a:p>
@@ -5273,7 +5381,7 @@
           <a:p>
             <a:fld id="{4509A250-FF31-4206-8172-F9D3106AACB1}" type="datetimeFigureOut">
               <a:rPr lang="en-US" dirty="0"/>
-              <a:t>5/6/2026</a:t>
+              <a:t>5/7/2026</a:t>
             </a:fld>
             <a:endParaRPr lang="en-US" dirty="0"/>
           </a:p>
@@ -5315,7 +5423,7 @@
           <a:p>
             <a:fld id="{D57F1E4F-1CFF-5643-939E-02111984F565}" type="slidenum">
               <a:rPr lang="en-US" dirty="0"/>
-              <a:t>‹#›</a:t>
+              <a:t>‹N›</a:t>
             </a:fld>
             <a:endParaRPr lang="en-US" dirty="0"/>
           </a:p>
@@ -5543,7 +5651,7 @@
           <a:p>
             <a:fld id="{4509A250-FF31-4206-8172-F9D3106AACB1}" type="datetimeFigureOut">
               <a:rPr lang="en-US" dirty="0"/>
-              <a:t>5/6/2026</a:t>
+              <a:t>5/7/2026</a:t>
             </a:fld>
             <a:endParaRPr lang="en-US" dirty="0"/>
           </a:p>
@@ -5585,7 +5693,7 @@
           <a:p>
             <a:fld id="{D57F1E4F-1CFF-5643-939E-02111984F565}" type="slidenum">
               <a:rPr lang="en-US" dirty="0"/>
-              <a:t>‹#›</a:t>
+              <a:t>‹N›</a:t>
             </a:fld>
             <a:endParaRPr lang="en-US" dirty="0"/>
           </a:p>
@@ -5741,6 +5849,13 @@
             <a:schemeClr val="lt1"/>
           </a:fontRef>
         </p:style>
+        <p:txBody>
+          <a:bodyPr/>
+          <a:lstStyle/>
+          <a:p>
+            <a:endParaRPr lang="it-CH"/>
+          </a:p>
+        </p:txBody>
       </p:sp>
       <p:pic>
         <p:nvPicPr>
@@ -5835,6 +5950,13 @@
             <a:schemeClr val="lt1"/>
           </a:fontRef>
         </p:style>
+        <p:txBody>
+          <a:bodyPr/>
+          <a:lstStyle/>
+          <a:p>
+            <a:endParaRPr lang="it-CH"/>
+          </a:p>
+        </p:txBody>
       </p:sp>
       <p:sp>
         <p:nvSpPr>
@@ -5967,7 +6089,7 @@
           <a:p>
             <a:fld id="{4AAD347D-5ACD-4C99-B74B-A9C85AD731AF}" type="datetimeFigureOut">
               <a:rPr lang="en-US" dirty="0"/>
-              <a:t>5/6/2026</a:t>
+              <a:t>5/7/2026</a:t>
             </a:fld>
             <a:endParaRPr lang="en-US" dirty="0"/>
           </a:p>
@@ -6046,7 +6168,7 @@
           <a:p>
             <a:fld id="{D57F1E4F-1CFF-5643-939E-02111984F565}" type="slidenum">
               <a:rPr lang="en-US" dirty="0"/>
-              <a:t>‹#›</a:t>
+              <a:t>‹N›</a:t>
             </a:fld>
             <a:endParaRPr lang="en-US" dirty="0"/>
           </a:p>
@@ -6542,8 +6664,29 @@
           <a:p>
             <a:r>
               <a:rPr lang="it-CH" dirty="0"/>
-              <a:t>Dennis donofrio</a:t>
-            </a:r>
+              <a:t>Dennis </a:t>
+            </a:r>
+            <a:r>
+              <a:rPr lang="it-CH" dirty="0" err="1"/>
+              <a:t>donofrio</a:t>
+            </a:r>
+            <a:r>
+              <a:rPr lang="it-CH" dirty="0"/>
+              <a:t> e </a:t>
+            </a:r>
+            <a:r>
+              <a:rPr lang="it-CH" dirty="0" err="1"/>
+              <a:t>manuel</a:t>
+            </a:r>
+            <a:r>
+              <a:rPr lang="it-CH" dirty="0"/>
+              <a:t> </a:t>
+            </a:r>
+            <a:r>
+              <a:rPr lang="it-CH" dirty="0" err="1"/>
+              <a:t>gabrieli</a:t>
+            </a:r>
+            <a:endParaRPr lang="it-CH" dirty="0"/>
           </a:p>
         </p:txBody>
       </p:sp>
@@ -6742,8 +6885,12 @@
           </a:p>
           <a:p>
             <a:r>
+              <a:rPr lang="it-CH" dirty="0" err="1"/>
+              <a:t>Popularity</a:t>
+            </a:r>
+            <a:r>
               <a:rPr lang="it-CH" dirty="0"/>
-              <a:t>Popularity -&gt; calcolato da spotify</a:t>
+              <a:t> 0 100 -&gt; calcolato da spotify</a:t>
             </a:r>
           </a:p>
           <a:p>

</xml_diff>

<commit_message>
Grafico aggiunto e presentazione aggiornata
</commit_message>
<xml_diff>
--- a/Spotify Tracks Dataset.pptx
+++ b/Spotify Tracks Dataset.pptx
@@ -5,7 +5,7 @@
     <p:sldMasterId id="2147483648" r:id="rId1"/>
   </p:sldMasterIdLst>
   <p:notesMasterIdLst>
-    <p:notesMasterId r:id="rId8"/>
+    <p:notesMasterId r:id="rId9"/>
   </p:notesMasterIdLst>
   <p:sldIdLst>
     <p:sldId id="256" r:id="rId2"/>
@@ -14,6 +14,7 @@
     <p:sldId id="259" r:id="rId5"/>
     <p:sldId id="261" r:id="rId6"/>
     <p:sldId id="260" r:id="rId7"/>
+    <p:sldId id="262" r:id="rId8"/>
   </p:sldIdLst>
   <p:sldSz cx="12192000" cy="6858000"/>
   <p:notesSz cx="6858000" cy="9144000"/>
@@ -202,7 +203,7 @@
           <a:p>
             <a:fld id="{A0B6E5F0-6A36-4198-8838-CB73C43E7E33}" type="datetimeFigureOut">
               <a:rPr lang="it-CH" smtClean="0"/>
-              <a:t>20.05.26</a:t>
+              <a:t>21.05.2026</a:t>
             </a:fld>
             <a:endParaRPr lang="it-CH"/>
           </a:p>
@@ -361,7 +362,7 @@
           <a:p>
             <a:fld id="{8BE94A0A-3E9B-4675-9F00-F14DBC49534D}" type="slidenum">
               <a:rPr lang="it-CH" smtClean="0"/>
-              <a:t>‹N›</a:t>
+              <a:t>‹#›</a:t>
             </a:fld>
             <a:endParaRPr lang="it-CH"/>
           </a:p>
@@ -711,6 +712,147 @@
 </p:notes>
 </file>
 
+<file path=ppt/notesSlides/notesSlide3.xml><?xml version="1.0" encoding="utf-8"?>
+<p:notes xmlns:a="http://schemas.openxmlformats.org/drawingml/2006/main" xmlns:r="http://schemas.openxmlformats.org/officeDocument/2006/relationships" xmlns:p="http://schemas.openxmlformats.org/presentationml/2006/main">
+  <p:cSld>
+    <p:spTree>
+      <p:nvGrpSpPr>
+        <p:cNvPr id="1" name=""/>
+        <p:cNvGrpSpPr/>
+        <p:nvPr/>
+      </p:nvGrpSpPr>
+      <p:grpSpPr>
+        <a:xfrm>
+          <a:off x="0" y="0"/>
+          <a:ext cx="0" cy="0"/>
+          <a:chOff x="0" y="0"/>
+          <a:chExt cx="0" cy="0"/>
+        </a:xfrm>
+      </p:grpSpPr>
+      <p:sp>
+        <p:nvSpPr>
+          <p:cNvPr id="2" name="Slide Image Placeholder 1"/>
+          <p:cNvSpPr>
+            <a:spLocks noGrp="1" noRot="1" noChangeAspect="1"/>
+          </p:cNvSpPr>
+          <p:nvPr>
+            <p:ph type="sldImg"/>
+          </p:nvPr>
+        </p:nvSpPr>
+        <p:spPr/>
+      </p:sp>
+      <p:sp>
+        <p:nvSpPr>
+          <p:cNvPr id="3" name="Notes Placeholder 2"/>
+          <p:cNvSpPr>
+            <a:spLocks noGrp="1"/>
+          </p:cNvSpPr>
+          <p:nvPr>
+            <p:ph type="body" idx="1"/>
+          </p:nvPr>
+        </p:nvSpPr>
+        <p:spPr/>
+        <p:txBody>
+          <a:bodyPr/>
+          <a:lstStyle/>
+          <a:p>
+            <a:r>
+              <a:rPr lang="it-CH" dirty="0"/>
+              <a:t>Popularity: popolarità su spotify da 0 a 100</a:t>
+            </a:r>
+          </a:p>
+          <a:p>
+            <a:r>
+              <a:rPr lang="it-CH" dirty="0"/>
+              <a:t>Danceability: quanto è adatta al ballo, ricavato da ritmo, stabilita del beat, velocita, regolarita musicale</a:t>
+            </a:r>
+          </a:p>
+          <a:p>
+            <a:r>
+              <a:rPr lang="it-CH" dirty="0"/>
+              <a:t>Energy: canzoni veloci, rumorose, dinamiche</a:t>
+            </a:r>
+          </a:p>
+          <a:p>
+            <a:r>
+              <a:rPr lang="it-CH" dirty="0"/>
+              <a:t>Loudness: volume medio della canzone</a:t>
+            </a:r>
+          </a:p>
+          <a:p>
+            <a:r>
+              <a:rPr lang="it-CH" dirty="0"/>
+              <a:t>Speechiness: presenza di parole parlate nel brano</a:t>
+            </a:r>
+          </a:p>
+          <a:p>
+            <a:r>
+              <a:rPr lang="it-CH" dirty="0"/>
+              <a:t>Acousticness: quanto e acustica, tanti strumenti naturali e pochi effetti elettronici</a:t>
+            </a:r>
+          </a:p>
+          <a:p>
+            <a:r>
+              <a:rPr lang="it-CH" dirty="0"/>
+              <a:t>Instrumentalness: probabilita che una canzone non contenga voce</a:t>
+            </a:r>
+          </a:p>
+          <a:p>
+            <a:r>
+              <a:rPr lang="it-CH" dirty="0"/>
+              <a:t>Liveness: probabilita che il brano e registrato dal vivo</a:t>
+            </a:r>
+          </a:p>
+          <a:p>
+            <a:r>
+              <a:rPr lang="it-CH" dirty="0"/>
+              <a:t>Valence: mood emotivo della canzone, valori alti musica positiva, allegra, felice, valori bassi musica triste, malinconica, emotiva</a:t>
+            </a:r>
+          </a:p>
+          <a:p>
+            <a:r>
+              <a:rPr lang="it-CH"/>
+              <a:t>Tempo: velocita della canzone in bpm</a:t>
+            </a:r>
+          </a:p>
+        </p:txBody>
+      </p:sp>
+      <p:sp>
+        <p:nvSpPr>
+          <p:cNvPr id="4" name="Slide Number Placeholder 3"/>
+          <p:cNvSpPr>
+            <a:spLocks noGrp="1"/>
+          </p:cNvSpPr>
+          <p:nvPr>
+            <p:ph type="sldNum" sz="quarter" idx="5"/>
+          </p:nvPr>
+        </p:nvSpPr>
+        <p:spPr/>
+        <p:txBody>
+          <a:bodyPr/>
+          <a:lstStyle/>
+          <a:p>
+            <a:fld id="{8BE94A0A-3E9B-4675-9F00-F14DBC49534D}" type="slidenum">
+              <a:rPr lang="it-CH" smtClean="0"/>
+              <a:t>7</a:t>
+            </a:fld>
+            <a:endParaRPr lang="it-CH"/>
+          </a:p>
+        </p:txBody>
+      </p:sp>
+    </p:spTree>
+    <p:extLst>
+      <p:ext uri="{BB962C8B-B14F-4D97-AF65-F5344CB8AC3E}">
+        <p14:creationId xmlns:p14="http://schemas.microsoft.com/office/powerpoint/2010/main" val="1103423197"/>
+      </p:ext>
+    </p:extLst>
+  </p:cSld>
+  <p:clrMapOvr>
+    <a:masterClrMapping/>
+  </p:clrMapOvr>
+</p:notes>
+</file>
+
 <file path=ppt/slideLayouts/slideLayout1.xml><?xml version="1.0" encoding="utf-8"?>
 <p:sldLayout xmlns:a="http://schemas.openxmlformats.org/drawingml/2006/main" xmlns:r="http://schemas.openxmlformats.org/officeDocument/2006/relationships" xmlns:p="http://schemas.openxmlformats.org/presentationml/2006/main" type="title" preserve="1">
   <p:cSld name="Title Slide">
@@ -897,7 +1039,7 @@
           <a:p>
             <a:fld id="{4AAD347D-5ACD-4C99-B74B-A9C85AD731AF}" type="datetimeFigureOut">
               <a:rPr lang="en-US" dirty="0"/>
-              <a:t>5/20/26</a:t>
+              <a:t>5/21/2026</a:t>
             </a:fld>
             <a:endParaRPr lang="en-US" dirty="0"/>
           </a:p>
@@ -939,7 +1081,7 @@
           <a:p>
             <a:fld id="{D57F1E4F-1CFF-5643-939E-02111984F565}" type="slidenum">
               <a:rPr lang="en-US" dirty="0"/>
-              <a:t>‹N›</a:t>
+              <a:t>‹#›</a:t>
             </a:fld>
             <a:endParaRPr lang="en-US" dirty="0"/>
           </a:p>
@@ -1167,7 +1309,7 @@
           <a:p>
             <a:fld id="{4509A250-FF31-4206-8172-F9D3106AACB1}" type="datetimeFigureOut">
               <a:rPr lang="en-US" dirty="0"/>
-              <a:t>5/20/26</a:t>
+              <a:t>5/21/2026</a:t>
             </a:fld>
             <a:endParaRPr lang="en-US" dirty="0"/>
           </a:p>
@@ -1209,7 +1351,7 @@
           <a:p>
             <a:fld id="{D57F1E4F-1CFF-5643-939E-02111984F565}" type="slidenum">
               <a:rPr lang="en-US" dirty="0"/>
-              <a:t>‹N›</a:t>
+              <a:t>‹#›</a:t>
             </a:fld>
             <a:endParaRPr lang="en-US" dirty="0"/>
           </a:p>
@@ -1356,7 +1498,7 @@
           <a:p>
             <a:fld id="{4509A250-FF31-4206-8172-F9D3106AACB1}" type="datetimeFigureOut">
               <a:rPr lang="en-US" dirty="0"/>
-              <a:t>5/20/26</a:t>
+              <a:t>5/21/2026</a:t>
             </a:fld>
             <a:endParaRPr lang="en-US" dirty="0"/>
           </a:p>
@@ -1398,7 +1540,7 @@
           <a:p>
             <a:fld id="{D57F1E4F-1CFF-5643-939E-02111984F565}" type="slidenum">
               <a:rPr lang="en-US" dirty="0"/>
-              <a:t>‹N›</a:t>
+              <a:t>‹#›</a:t>
             </a:fld>
             <a:endParaRPr lang="en-US" dirty="0"/>
           </a:p>
@@ -1624,7 +1766,7 @@
           <a:p>
             <a:fld id="{4509A250-FF31-4206-8172-F9D3106AACB1}" type="datetimeFigureOut">
               <a:rPr lang="en-US" dirty="0"/>
-              <a:t>5/20/26</a:t>
+              <a:t>5/21/2026</a:t>
             </a:fld>
             <a:endParaRPr lang="en-US" dirty="0"/>
           </a:p>
@@ -1666,7 +1808,7 @@
           <a:p>
             <a:fld id="{D57F1E4F-1CFF-5643-939E-02111984F565}" type="slidenum">
               <a:rPr lang="en-US" dirty="0"/>
-              <a:t>‹N›</a:t>
+              <a:t>‹#›</a:t>
             </a:fld>
             <a:endParaRPr lang="en-US" dirty="0"/>
           </a:p>
@@ -1960,7 +2102,7 @@
           <a:p>
             <a:fld id="{4509A250-FF31-4206-8172-F9D3106AACB1}" type="datetimeFigureOut">
               <a:rPr lang="en-US" dirty="0"/>
-              <a:t>5/20/26</a:t>
+              <a:t>5/21/2026</a:t>
             </a:fld>
             <a:endParaRPr lang="en-US" dirty="0"/>
           </a:p>
@@ -2002,7 +2144,7 @@
           <a:p>
             <a:fld id="{D57F1E4F-1CFF-5643-939E-02111984F565}" type="slidenum">
               <a:rPr lang="en-US" dirty="0"/>
-              <a:t>‹N›</a:t>
+              <a:t>‹#›</a:t>
             </a:fld>
             <a:endParaRPr lang="en-US" dirty="0"/>
           </a:p>
@@ -2578,7 +2720,7 @@
           <a:p>
             <a:fld id="{4509A250-FF31-4206-8172-F9D3106AACB1}" type="datetimeFigureOut">
               <a:rPr lang="en-US" dirty="0"/>
-              <a:t>5/20/26</a:t>
+              <a:t>5/21/2026</a:t>
             </a:fld>
             <a:endParaRPr lang="en-US" dirty="0"/>
           </a:p>
@@ -2620,7 +2762,7 @@
           <a:p>
             <a:fld id="{D57F1E4F-1CFF-5643-939E-02111984F565}" type="slidenum">
               <a:rPr lang="en-US" dirty="0"/>
-              <a:t>‹N›</a:t>
+              <a:t>‹#›</a:t>
             </a:fld>
             <a:endParaRPr lang="en-US" dirty="0"/>
           </a:p>
@@ -3433,7 +3575,7 @@
           <a:p>
             <a:fld id="{4509A250-FF31-4206-8172-F9D3106AACB1}" type="datetimeFigureOut">
               <a:rPr lang="en-US" dirty="0"/>
-              <a:t>5/20/26</a:t>
+              <a:t>5/21/2026</a:t>
             </a:fld>
             <a:endParaRPr lang="en-US" dirty="0"/>
           </a:p>
@@ -3475,7 +3617,7 @@
           <a:p>
             <a:fld id="{D57F1E4F-1CFF-5643-939E-02111984F565}" type="slidenum">
               <a:rPr lang="en-US" dirty="0"/>
-              <a:t>‹N›</a:t>
+              <a:t>‹#›</a:t>
             </a:fld>
             <a:endParaRPr lang="en-US" dirty="0"/>
           </a:p>
@@ -3598,7 +3740,7 @@
           <a:p>
             <a:fld id="{4509A250-FF31-4206-8172-F9D3106AACB1}" type="datetimeFigureOut">
               <a:rPr lang="en-US" dirty="0"/>
-              <a:t>5/20/26</a:t>
+              <a:t>5/21/2026</a:t>
             </a:fld>
             <a:endParaRPr lang="en-US" dirty="0"/>
           </a:p>
@@ -3640,7 +3782,7 @@
           <a:p>
             <a:fld id="{D57F1E4F-1CFF-5643-939E-02111984F565}" type="slidenum">
               <a:rPr lang="en-US" dirty="0"/>
-              <a:t>‹N›</a:t>
+              <a:t>‹#›</a:t>
             </a:fld>
             <a:endParaRPr lang="en-US" dirty="0"/>
           </a:p>
@@ -3773,7 +3915,7 @@
           <a:p>
             <a:fld id="{4509A250-FF31-4206-8172-F9D3106AACB1}" type="datetimeFigureOut">
               <a:rPr lang="en-US" dirty="0"/>
-              <a:t>5/20/26</a:t>
+              <a:t>5/21/2026</a:t>
             </a:fld>
             <a:endParaRPr lang="en-US" dirty="0"/>
           </a:p>
@@ -3815,7 +3957,7 @@
           <a:p>
             <a:fld id="{D57F1E4F-1CFF-5643-939E-02111984F565}" type="slidenum">
               <a:rPr lang="en-US" dirty="0"/>
-              <a:t>‹N›</a:t>
+              <a:t>‹#›</a:t>
             </a:fld>
             <a:endParaRPr lang="en-US" dirty="0"/>
           </a:p>
@@ -3938,7 +4080,7 @@
           <a:p>
             <a:fld id="{4509A250-FF31-4206-8172-F9D3106AACB1}" type="datetimeFigureOut">
               <a:rPr lang="en-US" dirty="0"/>
-              <a:t>5/20/26</a:t>
+              <a:t>5/21/2026</a:t>
             </a:fld>
             <a:endParaRPr lang="en-US" dirty="0"/>
           </a:p>
@@ -3980,7 +4122,7 @@
           <a:p>
             <a:fld id="{D57F1E4F-1CFF-5643-939E-02111984F565}" type="slidenum">
               <a:rPr lang="en-US" dirty="0"/>
-              <a:t>‹N›</a:t>
+              <a:t>‹#›</a:t>
             </a:fld>
             <a:endParaRPr lang="en-US" dirty="0"/>
           </a:p>
@@ -4180,7 +4322,7 @@
           <a:p>
             <a:fld id="{9796027F-7875-4030-9381-8BD8C4F21935}" type="datetimeFigureOut">
               <a:rPr lang="en-US" dirty="0"/>
-              <a:t>5/20/26</a:t>
+              <a:t>5/21/2026</a:t>
             </a:fld>
             <a:endParaRPr lang="en-US" dirty="0"/>
           </a:p>
@@ -4222,7 +4364,7 @@
           <a:p>
             <a:fld id="{D57F1E4F-1CFF-5643-939E-02111984F565}" type="slidenum">
               <a:rPr lang="en-US" dirty="0"/>
-              <a:t>‹N›</a:t>
+              <a:t>‹#›</a:t>
             </a:fld>
             <a:endParaRPr lang="en-US" dirty="0"/>
           </a:p>
@@ -4467,7 +4609,7 @@
           <a:p>
             <a:fld id="{9796027F-7875-4030-9381-8BD8C4F21935}" type="datetimeFigureOut">
               <a:rPr lang="en-US" dirty="0"/>
-              <a:t>5/20/26</a:t>
+              <a:t>5/21/2026</a:t>
             </a:fld>
             <a:endParaRPr lang="en-US" dirty="0"/>
           </a:p>
@@ -4509,7 +4651,7 @@
           <a:p>
             <a:fld id="{D57F1E4F-1CFF-5643-939E-02111984F565}" type="slidenum">
               <a:rPr lang="en-US" dirty="0"/>
-              <a:t>‹N›</a:t>
+              <a:t>‹#›</a:t>
             </a:fld>
             <a:endParaRPr lang="en-US" dirty="0"/>
           </a:p>
@@ -4906,7 +5048,7 @@
           <a:p>
             <a:fld id="{9796027F-7875-4030-9381-8BD8C4F21935}" type="datetimeFigureOut">
               <a:rPr lang="en-US" dirty="0"/>
-              <a:t>5/20/26</a:t>
+              <a:t>5/21/2026</a:t>
             </a:fld>
             <a:endParaRPr lang="en-US" dirty="0"/>
           </a:p>
@@ -4948,7 +5090,7 @@
           <a:p>
             <a:fld id="{D57F1E4F-1CFF-5643-939E-02111984F565}" type="slidenum">
               <a:rPr lang="en-US" dirty="0"/>
-              <a:t>‹N›</a:t>
+              <a:t>‹#›</a:t>
             </a:fld>
             <a:endParaRPr lang="en-US" dirty="0"/>
           </a:p>
@@ -5019,7 +5161,7 @@
           <a:p>
             <a:fld id="{4509A250-FF31-4206-8172-F9D3106AACB1}" type="datetimeFigureOut">
               <a:rPr lang="en-US" dirty="0"/>
-              <a:t>5/20/26</a:t>
+              <a:t>5/21/2026</a:t>
             </a:fld>
             <a:endParaRPr lang="en-US" dirty="0"/>
           </a:p>
@@ -5061,7 +5203,7 @@
           <a:p>
             <a:fld id="{D57F1E4F-1CFF-5643-939E-02111984F565}" type="slidenum">
               <a:rPr lang="en-US" dirty="0"/>
-              <a:t>‹N›</a:t>
+              <a:t>‹#›</a:t>
             </a:fld>
             <a:endParaRPr lang="en-US" dirty="0"/>
           </a:p>
@@ -5109,7 +5251,7 @@
           <a:p>
             <a:fld id="{4509A250-FF31-4206-8172-F9D3106AACB1}" type="datetimeFigureOut">
               <a:rPr lang="en-US" dirty="0"/>
-              <a:t>5/20/26</a:t>
+              <a:t>5/21/2026</a:t>
             </a:fld>
             <a:endParaRPr lang="en-US" dirty="0"/>
           </a:p>
@@ -5151,7 +5293,7 @@
           <a:p>
             <a:fld id="{D57F1E4F-1CFF-5643-939E-02111984F565}" type="slidenum">
               <a:rPr lang="en-US" dirty="0"/>
-              <a:t>‹N›</a:t>
+              <a:t>‹#›</a:t>
             </a:fld>
             <a:endParaRPr lang="en-US" dirty="0"/>
           </a:p>
@@ -5383,7 +5525,7 @@
           <a:p>
             <a:fld id="{4509A250-FF31-4206-8172-F9D3106AACB1}" type="datetimeFigureOut">
               <a:rPr lang="en-US" dirty="0"/>
-              <a:t>5/20/26</a:t>
+              <a:t>5/21/2026</a:t>
             </a:fld>
             <a:endParaRPr lang="en-US" dirty="0"/>
           </a:p>
@@ -5425,7 +5567,7 @@
           <a:p>
             <a:fld id="{D57F1E4F-1CFF-5643-939E-02111984F565}" type="slidenum">
               <a:rPr lang="en-US" dirty="0"/>
-              <a:t>‹N›</a:t>
+              <a:t>‹#›</a:t>
             </a:fld>
             <a:endParaRPr lang="en-US" dirty="0"/>
           </a:p>
@@ -5653,7 +5795,7 @@
           <a:p>
             <a:fld id="{4509A250-FF31-4206-8172-F9D3106AACB1}" type="datetimeFigureOut">
               <a:rPr lang="en-US" dirty="0"/>
-              <a:t>5/20/26</a:t>
+              <a:t>5/21/2026</a:t>
             </a:fld>
             <a:endParaRPr lang="en-US" dirty="0"/>
           </a:p>
@@ -5695,7 +5837,7 @@
           <a:p>
             <a:fld id="{D57F1E4F-1CFF-5643-939E-02111984F565}" type="slidenum">
               <a:rPr lang="en-US" dirty="0"/>
-              <a:t>‹N›</a:t>
+              <a:t>‹#›</a:t>
             </a:fld>
             <a:endParaRPr lang="en-US" dirty="0"/>
           </a:p>
@@ -6091,7 +6233,7 @@
           <a:p>
             <a:fld id="{4AAD347D-5ACD-4C99-B74B-A9C85AD731AF}" type="datetimeFigureOut">
               <a:rPr lang="en-US" dirty="0"/>
-              <a:t>5/20/26</a:t>
+              <a:t>5/21/2026</a:t>
             </a:fld>
             <a:endParaRPr lang="en-US" dirty="0"/>
           </a:p>
@@ -6170,7 +6312,7 @@
           <a:p>
             <a:fld id="{D57F1E4F-1CFF-5643-939E-02111984F565}" type="slidenum">
               <a:rPr lang="en-US" dirty="0"/>
-              <a:t>‹N›</a:t>
+              <a:t>‹#›</a:t>
             </a:fld>
             <a:endParaRPr lang="en-US" dirty="0"/>
           </a:p>
@@ -7134,6 +7276,68 @@
     <p:extLst>
       <p:ext uri="{BB962C8B-B14F-4D97-AF65-F5344CB8AC3E}">
         <p14:creationId xmlns:p14="http://schemas.microsoft.com/office/powerpoint/2010/main" val="3087767562"/>
+      </p:ext>
+    </p:extLst>
+  </p:cSld>
+  <p:clrMapOvr>
+    <a:masterClrMapping/>
+  </p:clrMapOvr>
+</p:sld>
+</file>
+
+<file path=ppt/slides/slide7.xml><?xml version="1.0" encoding="utf-8"?>
+<p:sld xmlns:a="http://schemas.openxmlformats.org/drawingml/2006/main" xmlns:r="http://schemas.openxmlformats.org/officeDocument/2006/relationships" xmlns:p="http://schemas.openxmlformats.org/presentationml/2006/main">
+  <p:cSld>
+    <p:spTree>
+      <p:nvGrpSpPr>
+        <p:cNvPr id="1" name=""/>
+        <p:cNvGrpSpPr/>
+        <p:nvPr/>
+      </p:nvGrpSpPr>
+      <p:grpSpPr>
+        <a:xfrm>
+          <a:off x="0" y="0"/>
+          <a:ext cx="0" cy="0"/>
+          <a:chOff x="0" y="0"/>
+          <a:chExt cx="0" cy="0"/>
+        </a:xfrm>
+      </p:grpSpPr>
+      <p:pic>
+        <p:nvPicPr>
+          <p:cNvPr id="5" name="Content Placeholder 4">
+            <a:extLst>
+              <a:ext uri="{FF2B5EF4-FFF2-40B4-BE49-F238E27FC236}">
+                <a16:creationId xmlns:a16="http://schemas.microsoft.com/office/drawing/2014/main" id="{F847E9EB-B82C-6B71-FC66-67DDD326F7FC}"/>
+              </a:ext>
+            </a:extLst>
+          </p:cNvPr>
+          <p:cNvPicPr>
+            <a:picLocks noGrp="1" noChangeAspect="1"/>
+          </p:cNvPicPr>
+          <p:nvPr>
+            <p:ph idx="1"/>
+          </p:nvPr>
+        </p:nvPicPr>
+        <p:blipFill>
+          <a:blip r:embed="rId3"/>
+          <a:stretch>
+            <a:fillRect/>
+          </a:stretch>
+        </p:blipFill>
+        <p:spPr>
+          <a:xfrm>
+            <a:off x="3067570" y="737062"/>
+            <a:ext cx="6056860" cy="5383876"/>
+          </a:xfrm>
+          <a:prstGeom prst="rect">
+            <a:avLst/>
+          </a:prstGeom>
+        </p:spPr>
+      </p:pic>
+    </p:spTree>
+    <p:extLst>
+      <p:ext uri="{BB962C8B-B14F-4D97-AF65-F5344CB8AC3E}">
+        <p14:creationId xmlns:p14="http://schemas.microsoft.com/office/powerpoint/2010/main" val="583457935"/>
       </p:ext>
     </p:extLst>
   </p:cSld>

</xml_diff>